<commit_message>
Add day 8 materials
</commit_message>
<xml_diff>
--- a/заняття_7/презентація/lesson7_ml_models.pptx
+++ b/заняття_7/презентація/lesson7_ml_models.pptx
@@ -307,10 +307,7 @@
           <a:bodyPr/>
           <a:lstStyle/>
           <a:p>
-            <a:r>
-              <a:rPr lang="en-US" dirty="0"/>
-              <a:t>Вітання групи. Сьогодні не новий алгоритм — а системне порівняння підходів. Нагадати pipeline з заняття 6.</a:t>
-            </a:r>
+            <a:endParaRPr lang="en-US" dirty="0"/>
           </a:p>
         </p:txBody>
       </p:sp>
@@ -401,10 +398,7 @@
           <a:bodyPr/>
           <a:lstStyle/>
           <a:p>
-            <a:r>
-              <a:rPr lang="en-US" dirty="0"/>
-              <a:t>Звернути увагу: MedInc (середній дохід) домінує — 52% важливості. Запитати: чому саме ця ознака? Що буде якщо max_depth=None?</a:t>
-            </a:r>
+            <a:endParaRPr lang="en-US" dirty="0"/>
           </a:p>
         </p:txBody>
       </p:sp>
@@ -495,10 +489,7 @@
           <a:bodyPr/>
           <a:lstStyle/>
           <a:p>
-            <a:r>
-              <a:rPr lang="en-US" dirty="0"/>
-              <a:t>Пояснити bootstrap sampling і random features — чому дерева різні. Test R² зріс 0.74→0.81 без будь-якого тюнінгу.</a:t>
-            </a:r>
+            <a:endParaRPr lang="en-US" dirty="0"/>
           </a:p>
         </p:txBody>
       </p:sp>
@@ -589,10 +580,7 @@
           <a:bodyPr/>
           <a:lstStyle/>
           <a:p>
-            <a:r>
-              <a:rPr lang="en-US" dirty="0"/>
-              <a:t>XGBoost виграв більшість Kaggle-змагань 2016-2020. Fallback через sklearn важливий — не у всіх може бути встановлений xgboost.</a:t>
-            </a:r>
+            <a:endParaRPr lang="en-US" dirty="0"/>
           </a:p>
         </p:txBody>
       </p:sp>
@@ -683,10 +671,7 @@
           <a:bodyPr/>
           <a:lstStyle/>
           <a:p>
-            <a:r>
-              <a:rPr lang="en-US" dirty="0"/>
-              <a:t>Зупинитись на рядку XGBoost. Запитати: чому DecisionTree має найвищий train R² але найнижчий test R²? Це наочний overfitting.</a:t>
-            </a:r>
+            <a:endParaRPr lang="en-US" dirty="0"/>
           </a:p>
         </p:txBody>
       </p:sp>
@@ -777,10 +762,7 @@
           <a:bodyPr/>
           <a:lstStyle/>
           <a:p>
-            <a:r>
-              <a:rPr lang="en-US" dirty="0"/>
-              <a:t>Поширена помилка студентів — рахувати R² для класифікатора. Підкреслити: зміна типу задачі = зміна метрик.</a:t>
-            </a:r>
+            <a:endParaRPr lang="en-US" dirty="0"/>
           </a:p>
         </p:txBody>
       </p:sp>
@@ -871,10 +853,7 @@
           <a:bodyPr/>
           <a:lstStyle/>
           <a:p>
-            <a:r>
-              <a:rPr lang="en-US" dirty="0"/>
-              <a:t>max_iter=1000 потрібен бо датасет великий — за замовчуванням 100 ітерацій може не вистачити і буде ConvergenceWarning.</a:t>
-            </a:r>
+            <a:endParaRPr lang="en-US" dirty="0"/>
           </a:p>
         </p:txBody>
       </p:sp>
@@ -965,10 +944,7 @@
           <a:bodyPr/>
           <a:lstStyle/>
           <a:p>
-            <a:r>
-              <a:rPr lang="en-US" dirty="0"/>
-              <a:t>Confusion matrix — фундамент всіх метрик класифікації. Пройтись по кожному квадранту з реальним прикладом про діагностику раку.</a:t>
-            </a:r>
+            <a:endParaRPr lang="en-US" dirty="0"/>
           </a:p>
         </p:txBody>
       </p:sp>
@@ -1059,10 +1035,7 @@
           <a:bodyPr/>
           <a:lstStyle/>
           <a:p>
-            <a:r>
-              <a:rPr lang="en-US" dirty="0"/>
-              <a:t>Формули виводити поступово. Precision: 'Скільки із знайдених дійсно хворі'. Recall: 'Скільки з усіх хворих знайшли'. F1 — якщо треба одна цифра.</a:t>
-            </a:r>
+            <a:endParaRPr lang="en-US" dirty="0"/>
           </a:p>
         </p:txBody>
       </p:sp>
@@ -1153,10 +1126,7 @@
           <a:bodyPr/>
           <a:lstStyle/>
           <a:p>
-            <a:r>
-              <a:rPr lang="en-US" dirty="0"/>
-              <a:t>Цей приклад студенти запам'ятовують назавжди. Accuracy здається гарною — але модель нічому не навчилась. Це класичний imbalanced dataset.</a:t>
-            </a:r>
+            <a:endParaRPr lang="en-US" dirty="0"/>
           </a:p>
         </p:txBody>
       </p:sp>
@@ -1247,10 +1217,7 @@
           <a:bodyPr/>
           <a:lstStyle/>
           <a:p>
-            <a:r>
-              <a:rPr lang="en-US" dirty="0"/>
-              <a:t>Пройтись по кожній помилці з прикладом з коду. Запитати студентів: хто з вас робив таку помилку? Це нормально — головне знати тепер.</a:t>
-            </a:r>
+            <a:endParaRPr lang="en-US" dirty="0"/>
           </a:p>
         </p:txBody>
       </p:sp>
@@ -1341,10 +1308,7 @@
           <a:bodyPr/>
           <a:lstStyle/>
           <a:p>
-            <a:r>
-              <a:rPr lang="en-US" dirty="0"/>
-              <a:t>Показати план — студенти мають розуміти, куди рухаємось. Акцент: сьогодні ми порівнюємо, а не вивчаємо алгоритми ізольовано.</a:t>
-            </a:r>
+            <a:endParaRPr lang="en-US" dirty="0"/>
           </a:p>
         </p:txBody>
       </p:sp>
@@ -1435,10 +1399,7 @@
           <a:bodyPr/>
           <a:lstStyle/>
           <a:p>
-            <a:r>
-              <a:rPr lang="en-US" dirty="0"/>
-              <a:t>Фінальне питання до групи по колу. Хай кожен назве одну річ, яку дізнався сьогодні.</a:t>
-            </a:r>
+            <a:endParaRPr lang="en-US" dirty="0"/>
           </a:p>
         </p:txBody>
       </p:sp>
@@ -1529,10 +1490,7 @@
           <a:bodyPr/>
           <a:lstStyle/>
           <a:p>
-            <a:r>
-              <a:rPr lang="en-US" dirty="0"/>
-              <a:t>Пояснити: ми буквально множимо ознаки на себе, створюючи нові. Ефект — крива може 'гнутись' як завгодно. Запитати студентів: що буде з degree=100?</a:t>
-            </a:r>
+            <a:endParaRPr lang="en-US" dirty="0"/>
           </a:p>
         </p:txBody>
       </p:sp>
@@ -1623,10 +1581,7 @@
           <a:bodyPr/>
           <a:lstStyle/>
           <a:p>
-            <a:r>
-              <a:rPr lang="en-US" dirty="0"/>
-              <a:t>Попросити студентів подивитись на train R² degree=10 — виглядає ідеально. Потім показати test R². Це і є overfitting.</a:t>
-            </a:r>
+            <a:endParaRPr lang="en-US" dirty="0"/>
           </a:p>
         </p:txBody>
       </p:sp>
@@ -1717,10 +1672,7 @@
           <a:bodyPr/>
           <a:lstStyle/>
           <a:p>
-            <a:r>
-              <a:rPr lang="en-US" dirty="0"/>
-              <a:t>Ключовий момент заняття — train vs test split. Повторити: чому ми не дивимось тільки на train.</a:t>
-            </a:r>
+            <a:endParaRPr lang="en-US" dirty="0"/>
           </a:p>
         </p:txBody>
       </p:sp>
@@ -1811,10 +1763,7 @@
           <a:bodyPr/>
           <a:lstStyle/>
           <a:p>
-            <a:r>
-              <a:rPr lang="en-US" dirty="0"/>
-              <a:t>Аналогія зі штрафом дуже добре сприймається. Акцент: ми не забороняємо модель бути складною — ми робимо це дорожче.</a:t>
-            </a:r>
+            <a:endParaRPr lang="en-US" dirty="0"/>
           </a:p>
         </p:txBody>
       </p:sp>
@@ -1905,18 +1854,7 @@
           <a:bodyPr/>
           <a:lstStyle/>
           <a:p>
-            <a:r>
-              <a:rPr lang="en-US" dirty="0"/>
-              <a:t>Головна різниця: Lasso може занулити ознаки — це вбудована feature selection. Ridge — ні. Запитати: </a:t>
-            </a:r>
-            <a:r>
-              <a:rPr lang="en-US" dirty="0" err="1"/>
-              <a:t>коли</a:t>
-            </a:r>
-            <a:r>
-              <a:rPr lang="en-US" dirty="0"/>
-              <a:t> ви б обрали Lasso?</a:t>
-            </a:r>
+            <a:endParaRPr lang="en-US" dirty="0"/>
           </a:p>
         </p:txBody>
       </p:sp>
@@ -2007,10 +1945,7 @@
           <a:bodyPr/>
           <a:lstStyle/>
           <a:p>
-            <a:r>
-              <a:rPr lang="en-US" dirty="0"/>
-              <a:t>Live coding або показати готовий результат. Запитати: чому у Lasso тільки 3 ненульових, а test R² навіть трохи кращий?</a:t>
-            </a:r>
+            <a:endParaRPr lang="en-US" dirty="0"/>
           </a:p>
         </p:txBody>
       </p:sp>
@@ -2101,10 +2036,7 @@
           <a:bodyPr/>
           <a:lstStyle/>
           <a:p>
-            <a:r>
-              <a:rPr lang="en-US" dirty="0"/>
-              <a:t>Схема — ключ до розуміння. Пройтись по дереву разом зі студентами: 'MedInc &gt; 5 — Так — Rooms &gt; 4 — Так — висока ціна'.</a:t>
-            </a:r>
+            <a:endParaRPr lang="en-US" dirty="0"/>
           </a:p>
         </p:txBody>
       </p:sp>

</xml_diff>